<commit_message>
Demo dosyalari düzenlendi ve son küçük değişiklikler sunumda ve modellerde yapıldı.
</commit_message>
<xml_diff>
--- a/SUNUM.pptx
+++ b/SUNUM.pptx
@@ -12,9 +12,11 @@
     <p:sldId id="260" r:id="rId6"/>
     <p:sldId id="261" r:id="rId7"/>
     <p:sldId id="262" r:id="rId8"/>
-    <p:sldId id="263" r:id="rId9"/>
-    <p:sldId id="264" r:id="rId10"/>
-    <p:sldId id="265" r:id="rId11"/>
+    <p:sldId id="267" r:id="rId9"/>
+    <p:sldId id="263" r:id="rId10"/>
+    <p:sldId id="266" r:id="rId11"/>
+    <p:sldId id="264" r:id="rId12"/>
+    <p:sldId id="265" r:id="rId13"/>
   </p:sldIdLst>
   <p:sldSz cx="12192000" cy="6858000"/>
   <p:notesSz cx="6858000" cy="9144000"/>
@@ -113,6 +115,11 @@
       </a:defRPr>
     </a:lvl9pPr>
   </p:defaultTextStyle>
+  <p:extLst>
+    <p:ext uri="{EFAFB233-063F-42B5-8137-9DF3F51BA10A}">
+      <p15:sldGuideLst xmlns:p15="http://schemas.microsoft.com/office/powerpoint/2012/main"/>
+    </p:ext>
+  </p:extLst>
 </p:presentation>
 </file>
 
@@ -255,7 +262,7 @@
           <a:p>
             <a:fld id="{5E39F47E-4FC3-4EE8-8007-8E58FAEDE401}" type="datetimeFigureOut">
               <a:rPr lang="tr-TR" smtClean="0"/>
-              <a:t>28.07.2025</a:t>
+              <a:t>30.07.2025</a:t>
             </a:fld>
             <a:endParaRPr lang="tr-TR"/>
           </a:p>
@@ -466,7 +473,7 @@
           <a:p>
             <a:fld id="{5E39F47E-4FC3-4EE8-8007-8E58FAEDE401}" type="datetimeFigureOut">
               <a:rPr lang="tr-TR" smtClean="0"/>
-              <a:t>28.07.2025</a:t>
+              <a:t>30.07.2025</a:t>
             </a:fld>
             <a:endParaRPr lang="tr-TR"/>
           </a:p>
@@ -681,7 +688,7 @@
           <a:p>
             <a:fld id="{5E39F47E-4FC3-4EE8-8007-8E58FAEDE401}" type="datetimeFigureOut">
               <a:rPr lang="tr-TR" smtClean="0"/>
-              <a:t>28.07.2025</a:t>
+              <a:t>30.07.2025</a:t>
             </a:fld>
             <a:endParaRPr lang="tr-TR"/>
           </a:p>
@@ -882,7 +889,7 @@
           <a:p>
             <a:fld id="{5E39F47E-4FC3-4EE8-8007-8E58FAEDE401}" type="datetimeFigureOut">
               <a:rPr lang="tr-TR" smtClean="0"/>
-              <a:t>28.07.2025</a:t>
+              <a:t>30.07.2025</a:t>
             </a:fld>
             <a:endParaRPr lang="tr-TR"/>
           </a:p>
@@ -1161,7 +1168,7 @@
           <a:p>
             <a:fld id="{5E39F47E-4FC3-4EE8-8007-8E58FAEDE401}" type="datetimeFigureOut">
               <a:rPr lang="tr-TR" smtClean="0"/>
-              <a:t>28.07.2025</a:t>
+              <a:t>30.07.2025</a:t>
             </a:fld>
             <a:endParaRPr lang="tr-TR"/>
           </a:p>
@@ -1429,7 +1436,7 @@
           <a:p>
             <a:fld id="{5E39F47E-4FC3-4EE8-8007-8E58FAEDE401}" type="datetimeFigureOut">
               <a:rPr lang="tr-TR" smtClean="0"/>
-              <a:t>28.07.2025</a:t>
+              <a:t>30.07.2025</a:t>
             </a:fld>
             <a:endParaRPr lang="tr-TR"/>
           </a:p>
@@ -1845,7 +1852,7 @@
           <a:p>
             <a:fld id="{5E39F47E-4FC3-4EE8-8007-8E58FAEDE401}" type="datetimeFigureOut">
               <a:rPr lang="tr-TR" smtClean="0"/>
-              <a:t>28.07.2025</a:t>
+              <a:t>30.07.2025</a:t>
             </a:fld>
             <a:endParaRPr lang="tr-TR"/>
           </a:p>
@@ -1994,7 +2001,7 @@
           <a:p>
             <a:fld id="{5E39F47E-4FC3-4EE8-8007-8E58FAEDE401}" type="datetimeFigureOut">
               <a:rPr lang="tr-TR" smtClean="0"/>
-              <a:t>28.07.2025</a:t>
+              <a:t>30.07.2025</a:t>
             </a:fld>
             <a:endParaRPr lang="tr-TR"/>
           </a:p>
@@ -2120,7 +2127,7 @@
           <a:p>
             <a:fld id="{5E39F47E-4FC3-4EE8-8007-8E58FAEDE401}" type="datetimeFigureOut">
               <a:rPr lang="tr-TR" smtClean="0"/>
-              <a:t>28.07.2025</a:t>
+              <a:t>30.07.2025</a:t>
             </a:fld>
             <a:endParaRPr lang="tr-TR"/>
           </a:p>
@@ -2371,7 +2378,7 @@
           <a:p>
             <a:fld id="{5E39F47E-4FC3-4EE8-8007-8E58FAEDE401}" type="datetimeFigureOut">
               <a:rPr lang="tr-TR" smtClean="0"/>
-              <a:t>28.07.2025</a:t>
+              <a:t>30.07.2025</a:t>
             </a:fld>
             <a:endParaRPr lang="tr-TR"/>
           </a:p>
@@ -2816,7 +2823,7 @@
           <a:p>
             <a:fld id="{5E39F47E-4FC3-4EE8-8007-8E58FAEDE401}" type="datetimeFigureOut">
               <a:rPr lang="tr-TR" smtClean="0"/>
-              <a:t>28.07.2025</a:t>
+              <a:t>30.07.2025</a:t>
             </a:fld>
             <a:endParaRPr lang="tr-TR"/>
           </a:p>
@@ -3143,7 +3150,7 @@
           <a:p>
             <a:fld id="{5E39F47E-4FC3-4EE8-8007-8E58FAEDE401}" type="datetimeFigureOut">
               <a:rPr lang="tr-TR" smtClean="0"/>
-              <a:t>28.07.2025</a:t>
+              <a:t>30.07.2025</a:t>
             </a:fld>
             <a:endParaRPr lang="tr-TR"/>
           </a:p>
@@ -3731,6 +3738,217 @@
           <p:cNvPr id="2" name="Title 1">
             <a:extLst>
               <a:ext uri="{FF2B5EF4-FFF2-40B4-BE49-F238E27FC236}">
+                <a16:creationId xmlns:a16="http://schemas.microsoft.com/office/drawing/2014/main" id="{0061D409-52EE-75E8-2E94-25B5D049E44A}"/>
+              </a:ext>
+            </a:extLst>
+          </p:cNvPr>
+          <p:cNvSpPr>
+            <a:spLocks noGrp="1"/>
+          </p:cNvSpPr>
+          <p:nvPr>
+            <p:ph type="title"/>
+          </p:nvPr>
+        </p:nvSpPr>
+        <p:spPr/>
+        <p:txBody>
+          <a:bodyPr/>
+          <a:lstStyle/>
+          <a:p>
+            <a:r>
+              <a:rPr lang="tr-TR" dirty="0"/>
+              <a:t>7. </a:t>
+            </a:r>
+            <a:r>
+              <a:rPr lang="tr-TR" b="1" dirty="0"/>
+              <a:t>Test Sonuçları ve Karşılaştırmalı Tablo(DATASET-11)Yöntem 2</a:t>
+            </a:r>
+            <a:endParaRPr lang="tr-TR" dirty="0"/>
+          </a:p>
+        </p:txBody>
+      </p:sp>
+      <p:pic>
+        <p:nvPicPr>
+          <p:cNvPr id="5" name="Content Placeholder 4">
+            <a:extLst>
+              <a:ext uri="{FF2B5EF4-FFF2-40B4-BE49-F238E27FC236}">
+                <a16:creationId xmlns:a16="http://schemas.microsoft.com/office/drawing/2014/main" id="{AEAA9FB8-4EA8-E15F-92F6-E9F061646F48}"/>
+              </a:ext>
+            </a:extLst>
+          </p:cNvPr>
+          <p:cNvPicPr>
+            <a:picLocks noGrp="1" noChangeAspect="1"/>
+          </p:cNvPicPr>
+          <p:nvPr>
+            <p:ph idx="1"/>
+          </p:nvPr>
+        </p:nvPicPr>
+        <p:blipFill>
+          <a:blip r:embed="rId2"/>
+          <a:stretch>
+            <a:fillRect/>
+          </a:stretch>
+        </p:blipFill>
+        <p:spPr>
+          <a:xfrm>
+            <a:off x="1809135" y="2526890"/>
+            <a:ext cx="7257197" cy="2689237"/>
+          </a:xfrm>
+        </p:spPr>
+      </p:pic>
+    </p:spTree>
+    <p:extLst>
+      <p:ext uri="{BB962C8B-B14F-4D97-AF65-F5344CB8AC3E}">
+        <p14:creationId xmlns:p14="http://schemas.microsoft.com/office/powerpoint/2010/main" val="329285241"/>
+      </p:ext>
+    </p:extLst>
+  </p:cSld>
+  <p:clrMapOvr>
+    <a:masterClrMapping/>
+  </p:clrMapOvr>
+</p:sld>
+</file>
+
+<file path=ppt/slides/slide11.xml><?xml version="1.0" encoding="utf-8"?>
+<p:sld xmlns:a="http://schemas.openxmlformats.org/drawingml/2006/main" xmlns:r="http://schemas.openxmlformats.org/officeDocument/2006/relationships" xmlns:p="http://schemas.openxmlformats.org/presentationml/2006/main">
+  <p:cSld>
+    <p:spTree>
+      <p:nvGrpSpPr>
+        <p:cNvPr id="1" name=""/>
+        <p:cNvGrpSpPr/>
+        <p:nvPr/>
+      </p:nvGrpSpPr>
+      <p:grpSpPr>
+        <a:xfrm>
+          <a:off x="0" y="0"/>
+          <a:ext cx="0" cy="0"/>
+          <a:chOff x="0" y="0"/>
+          <a:chExt cx="0" cy="0"/>
+        </a:xfrm>
+      </p:grpSpPr>
+      <p:sp>
+        <p:nvSpPr>
+          <p:cNvPr id="2" name="Title 1">
+            <a:extLst>
+              <a:ext uri="{FF2B5EF4-FFF2-40B4-BE49-F238E27FC236}">
+                <a16:creationId xmlns:a16="http://schemas.microsoft.com/office/drawing/2014/main" id="{36CE5F1F-41C9-D29C-9AC9-1763B61B8187}"/>
+              </a:ext>
+            </a:extLst>
+          </p:cNvPr>
+          <p:cNvSpPr>
+            <a:spLocks noGrp="1"/>
+          </p:cNvSpPr>
+          <p:nvPr>
+            <p:ph type="title"/>
+          </p:nvPr>
+        </p:nvSpPr>
+        <p:spPr/>
+        <p:txBody>
+          <a:bodyPr/>
+          <a:lstStyle/>
+          <a:p>
+            <a:endParaRPr lang="tr-TR" dirty="0"/>
+          </a:p>
+        </p:txBody>
+      </p:sp>
+      <p:sp>
+        <p:nvSpPr>
+          <p:cNvPr id="3" name="Content Placeholder 2">
+            <a:extLst>
+              <a:ext uri="{FF2B5EF4-FFF2-40B4-BE49-F238E27FC236}">
+                <a16:creationId xmlns:a16="http://schemas.microsoft.com/office/drawing/2014/main" id="{27C177BE-97C0-C143-B984-0D3670A88986}"/>
+              </a:ext>
+            </a:extLst>
+          </p:cNvPr>
+          <p:cNvSpPr>
+            <a:spLocks noGrp="1"/>
+          </p:cNvSpPr>
+          <p:nvPr>
+            <p:ph idx="1"/>
+          </p:nvPr>
+        </p:nvSpPr>
+        <p:spPr/>
+        <p:txBody>
+          <a:bodyPr/>
+          <a:lstStyle/>
+          <a:p>
+            <a:r>
+              <a:rPr lang="tr-TR" b="1" dirty="0"/>
+              <a:t>10. Tartışma ve Değerlendirme</a:t>
+            </a:r>
+          </a:p>
+          <a:p>
+            <a:pPr>
+              <a:buFont typeface="Arial" panose="020B0604020202020204" pitchFamily="34" charset="0"/>
+              <a:buChar char="•"/>
+            </a:pPr>
+            <a:r>
+              <a:rPr lang="tr-TR" dirty="0"/>
+              <a:t>LightGBM/SVM modelleri genelde en iyi sonuçları verdi</a:t>
+            </a:r>
+          </a:p>
+          <a:p>
+            <a:pPr>
+              <a:buFont typeface="Arial" panose="020B0604020202020204" pitchFamily="34" charset="0"/>
+              <a:buChar char="•"/>
+            </a:pPr>
+            <a:r>
+              <a:rPr lang="tr-TR" dirty="0"/>
+              <a:t>Veri büyüklüğü ve dağılımı, eğitim süresi ve skorlar üzerinde doğrudan etkili</a:t>
+            </a:r>
+          </a:p>
+          <a:p>
+            <a:pPr>
+              <a:buFont typeface="Arial" panose="020B0604020202020204" pitchFamily="34" charset="0"/>
+              <a:buChar char="•"/>
+            </a:pPr>
+            <a:r>
+              <a:rPr lang="tr-TR" dirty="0"/>
+              <a:t>LSTM daha fazla veriyle daha güçlü hale getirilebilir</a:t>
+            </a:r>
+          </a:p>
+          <a:p>
+            <a:pPr marL="0" indent="0">
+              <a:buNone/>
+            </a:pPr>
+            <a:endParaRPr lang="tr-TR" dirty="0"/>
+          </a:p>
+        </p:txBody>
+      </p:sp>
+    </p:spTree>
+    <p:extLst>
+      <p:ext uri="{BB962C8B-B14F-4D97-AF65-F5344CB8AC3E}">
+        <p14:creationId xmlns:p14="http://schemas.microsoft.com/office/powerpoint/2010/main" val="1040746950"/>
+      </p:ext>
+    </p:extLst>
+  </p:cSld>
+  <p:clrMapOvr>
+    <a:masterClrMapping/>
+  </p:clrMapOvr>
+</p:sld>
+</file>
+
+<file path=ppt/slides/slide12.xml><?xml version="1.0" encoding="utf-8"?>
+<p:sld xmlns:a="http://schemas.openxmlformats.org/drawingml/2006/main" xmlns:r="http://schemas.openxmlformats.org/officeDocument/2006/relationships" xmlns:p="http://schemas.openxmlformats.org/presentationml/2006/main">
+  <p:cSld>
+    <p:spTree>
+      <p:nvGrpSpPr>
+        <p:cNvPr id="1" name=""/>
+        <p:cNvGrpSpPr/>
+        <p:nvPr/>
+      </p:nvGrpSpPr>
+      <p:grpSpPr>
+        <a:xfrm>
+          <a:off x="0" y="0"/>
+          <a:ext cx="0" cy="0"/>
+          <a:chOff x="0" y="0"/>
+          <a:chExt cx="0" cy="0"/>
+        </a:xfrm>
+      </p:grpSpPr>
+      <p:sp>
+        <p:nvSpPr>
+          <p:cNvPr id="2" name="Title 1">
+            <a:extLst>
+              <a:ext uri="{FF2B5EF4-FFF2-40B4-BE49-F238E27FC236}">
                 <a16:creationId xmlns:a16="http://schemas.microsoft.com/office/drawing/2014/main" id="{683E743D-3B10-C0C7-F59D-D25F38E313BD}"/>
               </a:ext>
             </a:extLst>
@@ -4925,36 +5143,6 @@
       </p:pic>
       <p:pic>
         <p:nvPicPr>
-          <p:cNvPr id="5" name="Picture 4">
-            <a:extLst>
-              <a:ext uri="{FF2B5EF4-FFF2-40B4-BE49-F238E27FC236}">
-                <a16:creationId xmlns:a16="http://schemas.microsoft.com/office/drawing/2014/main" id="{9EA5FF4E-460B-2344-C2BF-BEAFF9613FF2}"/>
-              </a:ext>
-            </a:extLst>
-          </p:cNvPr>
-          <p:cNvPicPr>
-            <a:picLocks noChangeAspect="1"/>
-          </p:cNvPicPr>
-          <p:nvPr/>
-        </p:nvPicPr>
-        <p:blipFill>
-          <a:blip r:embed="rId3"/>
-          <a:stretch>
-            <a:fillRect/>
-          </a:stretch>
-        </p:blipFill>
-        <p:spPr>
-          <a:xfrm>
-            <a:off x="929618" y="2448233"/>
-            <a:ext cx="6749771" cy="4984954"/>
-          </a:xfrm>
-          <a:prstGeom prst="rect">
-            <a:avLst/>
-          </a:prstGeom>
-        </p:spPr>
-      </p:pic>
-      <p:pic>
-        <p:nvPicPr>
           <p:cNvPr id="11" name="Picture 10">
             <a:extLst>
               <a:ext uri="{FF2B5EF4-FFF2-40B4-BE49-F238E27FC236}">
@@ -4968,7 +5156,7 @@
           <p:nvPr/>
         </p:nvPicPr>
         <p:blipFill>
-          <a:blip r:embed="rId4"/>
+          <a:blip r:embed="rId3"/>
           <a:stretch>
             <a:fillRect/>
           </a:stretch>
@@ -5040,37 +5228,41 @@
             </a:r>
             <a:r>
               <a:rPr lang="tr-TR" b="1" dirty="0"/>
-              <a:t>Test Sonuçları ve Karşılaştırmalı Tablo(DATASET-11)</a:t>
+              <a:t>Test Sonuçları ve Karşılaştırmalı Tablo(DATASET-1Yöntem2)</a:t>
             </a:r>
             <a:endParaRPr lang="tr-TR" dirty="0"/>
           </a:p>
         </p:txBody>
       </p:sp>
-      <p:sp>
-        <p:nvSpPr>
-          <p:cNvPr id="7" name="Content Placeholder 6">
+      <p:pic>
+        <p:nvPicPr>
+          <p:cNvPr id="4" name="Content Placeholder 3">
             <a:extLst>
               <a:ext uri="{FF2B5EF4-FFF2-40B4-BE49-F238E27FC236}">
-                <a16:creationId xmlns:a16="http://schemas.microsoft.com/office/drawing/2014/main" id="{7077E1EF-DA91-4362-5E28-7465C4282E72}"/>
+                <a16:creationId xmlns:a16="http://schemas.microsoft.com/office/drawing/2014/main" id="{02535ABB-78E3-C8A3-93A1-878799FB7EA0}"/>
               </a:ext>
             </a:extLst>
           </p:cNvPr>
-          <p:cNvSpPr>
-            <a:spLocks noGrp="1"/>
-          </p:cNvSpPr>
+          <p:cNvPicPr>
+            <a:picLocks noGrp="1" noChangeAspect="1"/>
+          </p:cNvPicPr>
           <p:nvPr>
             <p:ph idx="1"/>
           </p:nvPr>
-        </p:nvSpPr>
-        <p:spPr/>
-        <p:txBody>
-          <a:bodyPr/>
-          <a:lstStyle/>
-          <a:p>
-            <a:endParaRPr lang="tr-TR"/>
-          </a:p>
-        </p:txBody>
-      </p:sp>
+        </p:nvPicPr>
+        <p:blipFill>
+          <a:blip r:embed="rId2"/>
+          <a:stretch>
+            <a:fillRect/>
+          </a:stretch>
+        </p:blipFill>
+        <p:spPr>
+          <a:xfrm>
+            <a:off x="2998839" y="2251587"/>
+            <a:ext cx="4885145" cy="3411793"/>
+          </a:xfrm>
+        </p:spPr>
+      </p:pic>
     </p:spTree>
     <p:extLst>
       <p:ext uri="{BB962C8B-B14F-4D97-AF65-F5344CB8AC3E}">
@@ -5085,6 +5277,94 @@
 </file>
 
 <file path=ppt/slides/slide8.xml><?xml version="1.0" encoding="utf-8"?>
+<p:sld xmlns:a="http://schemas.openxmlformats.org/drawingml/2006/main" xmlns:r="http://schemas.openxmlformats.org/officeDocument/2006/relationships" xmlns:p="http://schemas.openxmlformats.org/presentationml/2006/main">
+  <p:cSld>
+    <p:spTree>
+      <p:nvGrpSpPr>
+        <p:cNvPr id="1" name=""/>
+        <p:cNvGrpSpPr/>
+        <p:nvPr/>
+      </p:nvGrpSpPr>
+      <p:grpSpPr>
+        <a:xfrm>
+          <a:off x="0" y="0"/>
+          <a:ext cx="0" cy="0"/>
+          <a:chOff x="0" y="0"/>
+          <a:chExt cx="0" cy="0"/>
+        </a:xfrm>
+      </p:grpSpPr>
+      <p:sp>
+        <p:nvSpPr>
+          <p:cNvPr id="2" name="Title 1">
+            <a:extLst>
+              <a:ext uri="{FF2B5EF4-FFF2-40B4-BE49-F238E27FC236}">
+                <a16:creationId xmlns:a16="http://schemas.microsoft.com/office/drawing/2014/main" id="{E1445F4C-E697-4109-128B-20373D6DC156}"/>
+              </a:ext>
+            </a:extLst>
+          </p:cNvPr>
+          <p:cNvSpPr>
+            <a:spLocks noGrp="1"/>
+          </p:cNvSpPr>
+          <p:nvPr>
+            <p:ph type="title"/>
+          </p:nvPr>
+        </p:nvSpPr>
+        <p:spPr/>
+        <p:txBody>
+          <a:bodyPr/>
+          <a:lstStyle/>
+          <a:p>
+            <a:r>
+              <a:rPr lang="tr-TR" dirty="0"/>
+              <a:t>7. </a:t>
+            </a:r>
+            <a:r>
+              <a:rPr lang="tr-TR" b="1" dirty="0"/>
+              <a:t>Test Sonuçları ve Karşılaştırmalı Tablo(DATASET-11)</a:t>
+            </a:r>
+            <a:endParaRPr lang="tr-TR" dirty="0"/>
+          </a:p>
+        </p:txBody>
+      </p:sp>
+      <p:sp>
+        <p:nvSpPr>
+          <p:cNvPr id="3" name="Content Placeholder 2">
+            <a:extLst>
+              <a:ext uri="{FF2B5EF4-FFF2-40B4-BE49-F238E27FC236}">
+                <a16:creationId xmlns:a16="http://schemas.microsoft.com/office/drawing/2014/main" id="{1768779C-421B-3BFB-29F7-628065996A5B}"/>
+              </a:ext>
+            </a:extLst>
+          </p:cNvPr>
+          <p:cNvSpPr>
+            <a:spLocks noGrp="1"/>
+          </p:cNvSpPr>
+          <p:nvPr>
+            <p:ph idx="1"/>
+          </p:nvPr>
+        </p:nvSpPr>
+        <p:spPr/>
+        <p:txBody>
+          <a:bodyPr/>
+          <a:lstStyle/>
+          <a:p>
+            <a:endParaRPr lang="tr-TR" dirty="0"/>
+          </a:p>
+        </p:txBody>
+      </p:sp>
+    </p:spTree>
+    <p:extLst>
+      <p:ext uri="{BB962C8B-B14F-4D97-AF65-F5344CB8AC3E}">
+        <p14:creationId xmlns:p14="http://schemas.microsoft.com/office/powerpoint/2010/main" val="3458459640"/>
+      </p:ext>
+    </p:extLst>
+  </p:cSld>
+  <p:clrMapOvr>
+    <a:masterClrMapping/>
+  </p:clrMapOvr>
+</p:sld>
+</file>
+
+<file path=ppt/slides/slide9.xml><?xml version="1.0" encoding="utf-8"?>
 <p:sld xmlns:a="http://schemas.openxmlformats.org/drawingml/2006/main" xmlns:r="http://schemas.openxmlformats.org/officeDocument/2006/relationships" xmlns:p="http://schemas.openxmlformats.org/presentationml/2006/main">
   <p:cSld>
     <p:spTree>
@@ -5185,125 +5465,6 @@
     <p:extLst>
       <p:ext uri="{BB962C8B-B14F-4D97-AF65-F5344CB8AC3E}">
         <p14:creationId xmlns:p14="http://schemas.microsoft.com/office/powerpoint/2010/main" val="2444073378"/>
-      </p:ext>
-    </p:extLst>
-  </p:cSld>
-  <p:clrMapOvr>
-    <a:masterClrMapping/>
-  </p:clrMapOvr>
-</p:sld>
-</file>
-
-<file path=ppt/slides/slide9.xml><?xml version="1.0" encoding="utf-8"?>
-<p:sld xmlns:a="http://schemas.openxmlformats.org/drawingml/2006/main" xmlns:r="http://schemas.openxmlformats.org/officeDocument/2006/relationships" xmlns:p="http://schemas.openxmlformats.org/presentationml/2006/main">
-  <p:cSld>
-    <p:spTree>
-      <p:nvGrpSpPr>
-        <p:cNvPr id="1" name=""/>
-        <p:cNvGrpSpPr/>
-        <p:nvPr/>
-      </p:nvGrpSpPr>
-      <p:grpSpPr>
-        <a:xfrm>
-          <a:off x="0" y="0"/>
-          <a:ext cx="0" cy="0"/>
-          <a:chOff x="0" y="0"/>
-          <a:chExt cx="0" cy="0"/>
-        </a:xfrm>
-      </p:grpSpPr>
-      <p:sp>
-        <p:nvSpPr>
-          <p:cNvPr id="2" name="Title 1">
-            <a:extLst>
-              <a:ext uri="{FF2B5EF4-FFF2-40B4-BE49-F238E27FC236}">
-                <a16:creationId xmlns:a16="http://schemas.microsoft.com/office/drawing/2014/main" id="{36CE5F1F-41C9-D29C-9AC9-1763B61B8187}"/>
-              </a:ext>
-            </a:extLst>
-          </p:cNvPr>
-          <p:cNvSpPr>
-            <a:spLocks noGrp="1"/>
-          </p:cNvSpPr>
-          <p:nvPr>
-            <p:ph type="title"/>
-          </p:nvPr>
-        </p:nvSpPr>
-        <p:spPr/>
-        <p:txBody>
-          <a:bodyPr/>
-          <a:lstStyle/>
-          <a:p>
-            <a:endParaRPr lang="tr-TR" dirty="0"/>
-          </a:p>
-        </p:txBody>
-      </p:sp>
-      <p:sp>
-        <p:nvSpPr>
-          <p:cNvPr id="3" name="Content Placeholder 2">
-            <a:extLst>
-              <a:ext uri="{FF2B5EF4-FFF2-40B4-BE49-F238E27FC236}">
-                <a16:creationId xmlns:a16="http://schemas.microsoft.com/office/drawing/2014/main" id="{27C177BE-97C0-C143-B984-0D3670A88986}"/>
-              </a:ext>
-            </a:extLst>
-          </p:cNvPr>
-          <p:cNvSpPr>
-            <a:spLocks noGrp="1"/>
-          </p:cNvSpPr>
-          <p:nvPr>
-            <p:ph idx="1"/>
-          </p:nvPr>
-        </p:nvSpPr>
-        <p:spPr/>
-        <p:txBody>
-          <a:bodyPr/>
-          <a:lstStyle/>
-          <a:p>
-            <a:r>
-              <a:rPr lang="tr-TR" b="1" dirty="0"/>
-              <a:t>10. Tartışma ve Değerlendirme</a:t>
-            </a:r>
-          </a:p>
-          <a:p>
-            <a:pPr>
-              <a:buFont typeface="Arial" panose="020B0604020202020204" pitchFamily="34" charset="0"/>
-              <a:buChar char="•"/>
-            </a:pPr>
-            <a:r>
-              <a:rPr lang="tr-TR" dirty="0"/>
-              <a:t>LightGBM/SVM modelleri genelde en iyi sonuçları verdi</a:t>
-            </a:r>
-          </a:p>
-          <a:p>
-            <a:pPr>
-              <a:buFont typeface="Arial" panose="020B0604020202020204" pitchFamily="34" charset="0"/>
-              <a:buChar char="•"/>
-            </a:pPr>
-            <a:r>
-              <a:rPr lang="tr-TR" dirty="0"/>
-              <a:t>Veri büyüklüğü ve dağılımı, eğitim süresi ve skorlar üzerinde doğrudan etkili</a:t>
-            </a:r>
-          </a:p>
-          <a:p>
-            <a:pPr>
-              <a:buFont typeface="Arial" panose="020B0604020202020204" pitchFamily="34" charset="0"/>
-              <a:buChar char="•"/>
-            </a:pPr>
-            <a:r>
-              <a:rPr lang="tr-TR" dirty="0"/>
-              <a:t>LSTM daha fazla veriyle daha güçlü hale getirilebilir</a:t>
-            </a:r>
-          </a:p>
-          <a:p>
-            <a:pPr marL="0" indent="0">
-              <a:buNone/>
-            </a:pPr>
-            <a:endParaRPr lang="tr-TR" dirty="0"/>
-          </a:p>
-        </p:txBody>
-      </p:sp>
-    </p:spTree>
-    <p:extLst>
-      <p:ext uri="{BB962C8B-B14F-4D97-AF65-F5344CB8AC3E}">
-        <p14:creationId xmlns:p14="http://schemas.microsoft.com/office/powerpoint/2010/main" val="1040746950"/>
       </p:ext>
     </p:extLst>
   </p:cSld>

</xml_diff>

<commit_message>
Readme ve LSTM  guncellendi
</commit_message>
<xml_diff>
--- a/SUNUM.pptx
+++ b/SUNUM.pptx
@@ -12,11 +12,12 @@
     <p:sldId id="260" r:id="rId6"/>
     <p:sldId id="261" r:id="rId7"/>
     <p:sldId id="262" r:id="rId8"/>
-    <p:sldId id="267" r:id="rId9"/>
-    <p:sldId id="263" r:id="rId10"/>
-    <p:sldId id="266" r:id="rId11"/>
-    <p:sldId id="264" r:id="rId12"/>
-    <p:sldId id="265" r:id="rId13"/>
+    <p:sldId id="268" r:id="rId9"/>
+    <p:sldId id="267" r:id="rId10"/>
+    <p:sldId id="263" r:id="rId11"/>
+    <p:sldId id="266" r:id="rId12"/>
+    <p:sldId id="264" r:id="rId13"/>
+    <p:sldId id="265" r:id="rId14"/>
   </p:sldIdLst>
   <p:sldSz cx="12192000" cy="6858000"/>
   <p:notesSz cx="6858000" cy="9144000"/>
@@ -3738,6 +3739,116 @@
           <p:cNvPr id="2" name="Title 1">
             <a:extLst>
               <a:ext uri="{FF2B5EF4-FFF2-40B4-BE49-F238E27FC236}">
+                <a16:creationId xmlns:a16="http://schemas.microsoft.com/office/drawing/2014/main" id="{00B47676-C309-59AB-A1AB-3905CD9603B1}"/>
+              </a:ext>
+            </a:extLst>
+          </p:cNvPr>
+          <p:cNvSpPr>
+            <a:spLocks noGrp="1"/>
+          </p:cNvSpPr>
+          <p:nvPr>
+            <p:ph type="title"/>
+          </p:nvPr>
+        </p:nvSpPr>
+        <p:spPr/>
+        <p:txBody>
+          <a:bodyPr/>
+          <a:lstStyle/>
+          <a:p>
+            <a:endParaRPr lang="tr-TR"/>
+          </a:p>
+        </p:txBody>
+      </p:sp>
+      <p:sp>
+        <p:nvSpPr>
+          <p:cNvPr id="3" name="Content Placeholder 2">
+            <a:extLst>
+              <a:ext uri="{FF2B5EF4-FFF2-40B4-BE49-F238E27FC236}">
+                <a16:creationId xmlns:a16="http://schemas.microsoft.com/office/drawing/2014/main" id="{748E7F61-953B-CB89-FE9B-AF7DCD9E8545}"/>
+              </a:ext>
+            </a:extLst>
+          </p:cNvPr>
+          <p:cNvSpPr>
+            <a:spLocks noGrp="1"/>
+          </p:cNvSpPr>
+          <p:nvPr>
+            <p:ph idx="1"/>
+          </p:nvPr>
+        </p:nvSpPr>
+        <p:spPr/>
+        <p:txBody>
+          <a:bodyPr/>
+          <a:lstStyle/>
+          <a:p>
+            <a:endParaRPr lang="tr-TR"/>
+          </a:p>
+        </p:txBody>
+      </p:sp>
+      <p:pic>
+        <p:nvPicPr>
+          <p:cNvPr id="5" name="Content Placeholder 4">
+            <a:extLst>
+              <a:ext uri="{FF2B5EF4-FFF2-40B4-BE49-F238E27FC236}">
+                <a16:creationId xmlns:a16="http://schemas.microsoft.com/office/drawing/2014/main" id="{D8C1991D-2CCC-DBA3-3472-2F08242966F5}"/>
+              </a:ext>
+            </a:extLst>
+          </p:cNvPr>
+          <p:cNvPicPr>
+            <a:picLocks noChangeAspect="1"/>
+          </p:cNvPicPr>
+          <p:nvPr/>
+        </p:nvPicPr>
+        <p:blipFill>
+          <a:blip r:embed="rId2"/>
+          <a:stretch>
+            <a:fillRect/>
+          </a:stretch>
+        </p:blipFill>
+        <p:spPr>
+          <a:xfrm>
+            <a:off x="0" y="0"/>
+            <a:ext cx="12192000" cy="6931742"/>
+          </a:xfrm>
+          <a:prstGeom prst="rect">
+            <a:avLst/>
+          </a:prstGeom>
+        </p:spPr>
+      </p:pic>
+    </p:spTree>
+    <p:extLst>
+      <p:ext uri="{BB962C8B-B14F-4D97-AF65-F5344CB8AC3E}">
+        <p14:creationId xmlns:p14="http://schemas.microsoft.com/office/powerpoint/2010/main" val="2444073378"/>
+      </p:ext>
+    </p:extLst>
+  </p:cSld>
+  <p:clrMapOvr>
+    <a:masterClrMapping/>
+  </p:clrMapOvr>
+</p:sld>
+</file>
+
+<file path=ppt/slides/slide11.xml><?xml version="1.0" encoding="utf-8"?>
+<p:sld xmlns:a="http://schemas.openxmlformats.org/drawingml/2006/main" xmlns:r="http://schemas.openxmlformats.org/officeDocument/2006/relationships" xmlns:p="http://schemas.openxmlformats.org/presentationml/2006/main">
+  <p:cSld>
+    <p:spTree>
+      <p:nvGrpSpPr>
+        <p:cNvPr id="1" name=""/>
+        <p:cNvGrpSpPr/>
+        <p:nvPr/>
+      </p:nvGrpSpPr>
+      <p:grpSpPr>
+        <a:xfrm>
+          <a:off x="0" y="0"/>
+          <a:ext cx="0" cy="0"/>
+          <a:chOff x="0" y="0"/>
+          <a:chExt cx="0" cy="0"/>
+        </a:xfrm>
+      </p:grpSpPr>
+      <p:sp>
+        <p:nvSpPr>
+          <p:cNvPr id="2" name="Title 1">
+            <a:extLst>
+              <a:ext uri="{FF2B5EF4-FFF2-40B4-BE49-F238E27FC236}">
                 <a16:creationId xmlns:a16="http://schemas.microsoft.com/office/drawing/2014/main" id="{0061D409-52EE-75E8-2E94-25B5D049E44A}"/>
               </a:ext>
             </a:extLst>
@@ -3808,7 +3919,7 @@
 </p:sld>
 </file>
 
-<file path=ppt/slides/slide11.xml><?xml version="1.0" encoding="utf-8"?>
+<file path=ppt/slides/slide12.xml><?xml version="1.0" encoding="utf-8"?>
 <p:sld xmlns:a="http://schemas.openxmlformats.org/drawingml/2006/main" xmlns:r="http://schemas.openxmlformats.org/officeDocument/2006/relationships" xmlns:p="http://schemas.openxmlformats.org/presentationml/2006/main">
   <p:cSld>
     <p:spTree>
@@ -3927,7 +4038,7 @@
 </p:sld>
 </file>
 
-<file path=ppt/slides/slide12.xml><?xml version="1.0" encoding="utf-8"?>
+<file path=ppt/slides/slide13.xml><?xml version="1.0" encoding="utf-8"?>
 <p:sld xmlns:a="http://schemas.openxmlformats.org/drawingml/2006/main" xmlns:r="http://schemas.openxmlformats.org/officeDocument/2006/relationships" xmlns:p="http://schemas.openxmlformats.org/presentationml/2006/main">
   <p:cSld>
     <p:spTree>
@@ -5298,7 +5409,7 @@
           <p:cNvPr id="2" name="Title 1">
             <a:extLst>
               <a:ext uri="{FF2B5EF4-FFF2-40B4-BE49-F238E27FC236}">
-                <a16:creationId xmlns:a16="http://schemas.microsoft.com/office/drawing/2014/main" id="{E1445F4C-E697-4109-128B-20373D6DC156}"/>
+                <a16:creationId xmlns:a16="http://schemas.microsoft.com/office/drawing/2014/main" id="{ABE24EE7-3D5B-54D1-13CB-406AE97C2668}"/>
               </a:ext>
             </a:extLst>
           </p:cNvPr>
@@ -5309,19 +5420,16 @@
             <p:ph type="title"/>
           </p:nvPr>
         </p:nvSpPr>
-        <p:spPr/>
+        <p:spPr>
+          <a:xfrm>
+            <a:off x="1372921" y="304919"/>
+            <a:ext cx="9603275" cy="1049235"/>
+          </a:xfrm>
+        </p:spPr>
         <p:txBody>
           <a:bodyPr/>
           <a:lstStyle/>
           <a:p>
-            <a:r>
-              <a:rPr lang="tr-TR" dirty="0"/>
-              <a:t>7. </a:t>
-            </a:r>
-            <a:r>
-              <a:rPr lang="tr-TR" b="1" dirty="0"/>
-              <a:t>Test Sonuçları ve Karşılaştırmalı Tablo(DATASET-11)</a:t>
-            </a:r>
             <a:endParaRPr lang="tr-TR" dirty="0"/>
           </a:p>
         </p:txBody>
@@ -5331,7 +5439,7 @@
           <p:cNvPr id="3" name="Content Placeholder 2">
             <a:extLst>
               <a:ext uri="{FF2B5EF4-FFF2-40B4-BE49-F238E27FC236}">
-                <a16:creationId xmlns:a16="http://schemas.microsoft.com/office/drawing/2014/main" id="{1768779C-421B-3BFB-29F7-628065996A5B}"/>
+                <a16:creationId xmlns:a16="http://schemas.microsoft.com/office/drawing/2014/main" id="{8FB637B1-58E8-350B-103C-CD3E05F4399D}"/>
               </a:ext>
             </a:extLst>
           </p:cNvPr>
@@ -5342,10 +5450,259 @@
             <p:ph idx="1"/>
           </p:nvPr>
         </p:nvSpPr>
-        <p:spPr/>
-        <p:txBody>
-          <a:bodyPr/>
-          <a:lstStyle/>
+        <p:spPr>
+          <a:xfrm>
+            <a:off x="1372921" y="305038"/>
+            <a:ext cx="9603275" cy="3450613"/>
+          </a:xfrm>
+        </p:spPr>
+        <p:txBody>
+          <a:bodyPr>
+            <a:normAutofit fontScale="25000" lnSpcReduction="20000"/>
+          </a:bodyPr>
+          <a:lstStyle/>
+          <a:p>
+            <a:r>
+              <a:rPr lang="tr-TR" sz="4800" b="1" dirty="0"/>
+              <a:t>1. En Başarılı Model - LightGBM</a:t>
+            </a:r>
+          </a:p>
+          <a:p>
+            <a:pPr>
+              <a:buFont typeface="Arial" panose="020B0604020202020204" pitchFamily="34" charset="0"/>
+              <a:buChar char="•"/>
+            </a:pPr>
+            <a:r>
+              <a:rPr lang="tr-TR" sz="4800" b="1" dirty="0"/>
+              <a:t>Accuracy: 0.8974</a:t>
+            </a:r>
+            <a:r>
+              <a:rPr lang="tr-TR" sz="4800" dirty="0"/>
+              <a:t>, F1: </a:t>
+            </a:r>
+            <a:r>
+              <a:rPr lang="tr-TR" sz="4800" b="1" dirty="0"/>
+              <a:t>0.9</a:t>
+            </a:r>
+            <a:endParaRPr lang="tr-TR" sz="4800" dirty="0"/>
+          </a:p>
+          <a:p>
+            <a:pPr>
+              <a:buFont typeface="Arial" panose="020B0604020202020204" pitchFamily="34" charset="0"/>
+              <a:buChar char="•"/>
+            </a:pPr>
+            <a:r>
+              <a:rPr lang="tr-TR" sz="4800" dirty="0"/>
+              <a:t>Hem doğruluk (accuracy) hem de F1 skorunda en yüksek değeri LightGBM verdi.</a:t>
+            </a:r>
+          </a:p>
+          <a:p>
+            <a:pPr>
+              <a:buFont typeface="Arial" panose="020B0604020202020204" pitchFamily="34" charset="0"/>
+              <a:buChar char="•"/>
+            </a:pPr>
+            <a:r>
+              <a:rPr lang="tr-TR" sz="4800" b="1" dirty="0"/>
+              <a:t>Dengeli precision-recall oranları</a:t>
+            </a:r>
+            <a:r>
+              <a:rPr lang="tr-TR" sz="4800" dirty="0"/>
+              <a:t> var:</a:t>
+            </a:r>
+          </a:p>
+          <a:p>
+            <a:pPr marL="742950" lvl="1" indent="-285750">
+              <a:buFont typeface="Arial" panose="020B0604020202020204" pitchFamily="34" charset="0"/>
+              <a:buChar char="•"/>
+            </a:pPr>
+            <a:r>
+              <a:rPr lang="tr-TR" sz="4800" dirty="0"/>
+              <a:t>Sınıf 0: precision=0.9132, recall=0.8769</a:t>
+            </a:r>
+          </a:p>
+          <a:p>
+            <a:pPr marL="742950" lvl="1" indent="-285750">
+              <a:buFont typeface="Arial" panose="020B0604020202020204" pitchFamily="34" charset="0"/>
+              <a:buChar char="•"/>
+            </a:pPr>
+            <a:r>
+              <a:rPr lang="tr-TR" sz="4800" dirty="0"/>
+              <a:t>Sınıf 1: precision=0.8838, recall=0.9177</a:t>
+            </a:r>
+          </a:p>
+          <a:p>
+            <a:pPr>
+              <a:buFont typeface="Arial" panose="020B0604020202020204" pitchFamily="34" charset="0"/>
+              <a:buChar char="•"/>
+            </a:pPr>
+            <a:r>
+              <a:rPr lang="tr-TR" sz="4800" b="1" dirty="0"/>
+              <a:t>Yorum:</a:t>
+            </a:r>
+            <a:r>
+              <a:rPr lang="tr-TR" sz="4800" dirty="0"/>
+              <a:t> Hem sahte hem orijinal yorumları iyi ayırt ediyor. Özellikle sahte yorumları yüksek başarıyla (recall=0.9177) yakalıyor. Bu, sistemin sahte yorumları tespit etmede güçlü olduğunu gösteriyor.</a:t>
+            </a:r>
+          </a:p>
+          <a:p>
+            <a:r>
+              <a:rPr lang="tr-TR" sz="4800" b="1" dirty="0"/>
+              <a:t>2. SVM</a:t>
+            </a:r>
+          </a:p>
+          <a:p>
+            <a:pPr>
+              <a:buFont typeface="Arial" panose="020B0604020202020204" pitchFamily="34" charset="0"/>
+              <a:buChar char="•"/>
+            </a:pPr>
+            <a:r>
+              <a:rPr lang="tr-TR" sz="4800" b="1" dirty="0"/>
+              <a:t>Accuracy: 0.8930</a:t>
+            </a:r>
+            <a:r>
+              <a:rPr lang="tr-TR" sz="4800" dirty="0"/>
+              <a:t>, F1: </a:t>
+            </a:r>
+            <a:r>
+              <a:rPr lang="tr-TR" sz="4800" b="1" dirty="0"/>
+              <a:t>0.8952</a:t>
+            </a:r>
+            <a:endParaRPr lang="tr-TR" sz="4800" dirty="0"/>
+          </a:p>
+          <a:p>
+            <a:pPr>
+              <a:buFont typeface="Arial" panose="020B0604020202020204" pitchFamily="34" charset="0"/>
+              <a:buChar char="•"/>
+            </a:pPr>
+            <a:r>
+              <a:rPr lang="tr-TR" sz="4800" dirty="0"/>
+              <a:t>Sınıf 1 için </a:t>
+            </a:r>
+            <a:r>
+              <a:rPr lang="tr-TR" sz="4800" b="1" dirty="0"/>
+              <a:t>yüksek recall (0.9017)</a:t>
+            </a:r>
+            <a:r>
+              <a:rPr lang="tr-TR" sz="4800" dirty="0"/>
+              <a:t> ile sahte yorumları kaçırmıyor.</a:t>
+            </a:r>
+          </a:p>
+          <a:p>
+            <a:pPr>
+              <a:buFont typeface="Arial" panose="020B0604020202020204" pitchFamily="34" charset="0"/>
+              <a:buChar char="•"/>
+            </a:pPr>
+            <a:r>
+              <a:rPr lang="tr-TR" sz="4800" dirty="0"/>
+              <a:t>Fakat LightGBM'e göre bir tık geride.</a:t>
+            </a:r>
+          </a:p>
+          <a:p>
+            <a:r>
+              <a:rPr lang="tr-TR" sz="4800" b="1" dirty="0"/>
+              <a:t>3. Naive Bayes</a:t>
+            </a:r>
+          </a:p>
+          <a:p>
+            <a:pPr>
+              <a:buFont typeface="Arial" panose="020B0604020202020204" pitchFamily="34" charset="0"/>
+              <a:buChar char="•"/>
+            </a:pPr>
+            <a:r>
+              <a:rPr lang="tr-TR" sz="4800" dirty="0"/>
+              <a:t>Accuracy: </a:t>
+            </a:r>
+            <a:r>
+              <a:rPr lang="tr-TR" sz="4800" b="1" dirty="0"/>
+              <a:t>0.8281</a:t>
+            </a:r>
+            <a:r>
+              <a:rPr lang="tr-TR" sz="4800" dirty="0"/>
+              <a:t>, F1: </a:t>
+            </a:r>
+            <a:r>
+              <a:rPr lang="tr-TR" sz="4800" b="1" dirty="0"/>
+              <a:t>0.8257</a:t>
+            </a:r>
+            <a:endParaRPr lang="tr-TR" sz="4800" dirty="0"/>
+          </a:p>
+          <a:p>
+            <a:pPr>
+              <a:buFont typeface="Arial" panose="020B0604020202020204" pitchFamily="34" charset="0"/>
+              <a:buChar char="•"/>
+            </a:pPr>
+            <a:r>
+              <a:rPr lang="tr-TR" sz="4800" dirty="0"/>
+              <a:t>En düşük performansa sahip. Özellikle recall değeri sınıf 1 için düşük (0.8071).</a:t>
+            </a:r>
+          </a:p>
+          <a:p>
+            <a:pPr>
+              <a:buFont typeface="Arial" panose="020B0604020202020204" pitchFamily="34" charset="0"/>
+              <a:buChar char="•"/>
+            </a:pPr>
+            <a:r>
+              <a:rPr lang="tr-TR" sz="4800" b="1" dirty="0"/>
+              <a:t>Yorum:</a:t>
+            </a:r>
+            <a:r>
+              <a:rPr lang="tr-TR" sz="4800" dirty="0"/>
+              <a:t> Basit bir model, büyük veri setlerinde genellikle yetersiz kalır.</a:t>
+            </a:r>
+          </a:p>
+          <a:p>
+            <a:r>
+              <a:rPr lang="tr-TR" sz="4800" b="1" dirty="0"/>
+              <a:t>4. MLP</a:t>
+            </a:r>
+          </a:p>
+          <a:p>
+            <a:pPr>
+              <a:buFont typeface="Arial" panose="020B0604020202020204" pitchFamily="34" charset="0"/>
+              <a:buChar char="•"/>
+            </a:pPr>
+            <a:r>
+              <a:rPr lang="tr-TR" sz="4800" dirty="0"/>
+              <a:t>Accuracy: </a:t>
+            </a:r>
+            <a:r>
+              <a:rPr lang="tr-TR" sz="4800" b="1" dirty="0"/>
+              <a:t>0.8308</a:t>
+            </a:r>
+            <a:r>
+              <a:rPr lang="tr-TR" sz="4800" dirty="0"/>
+              <a:t>, F1: </a:t>
+            </a:r>
+            <a:r>
+              <a:rPr lang="tr-TR" sz="4800" b="1" dirty="0"/>
+              <a:t>0.8125</a:t>
+            </a:r>
+            <a:endParaRPr lang="tr-TR" sz="4800" dirty="0"/>
+          </a:p>
+          <a:p>
+            <a:pPr>
+              <a:buFont typeface="Arial" panose="020B0604020202020204" pitchFamily="34" charset="0"/>
+              <a:buChar char="•"/>
+            </a:pPr>
+            <a:r>
+              <a:rPr lang="tr-TR" sz="4800" dirty="0"/>
+              <a:t>Sınıf 1'de recall düşük: 0.7322</a:t>
+            </a:r>
+          </a:p>
+          <a:p>
+            <a:pPr>
+              <a:buFont typeface="Arial" panose="020B0604020202020204" pitchFamily="34" charset="0"/>
+              <a:buChar char="•"/>
+            </a:pPr>
+            <a:r>
+              <a:rPr lang="tr-TR" sz="4800" b="1" dirty="0"/>
+              <a:t>Yorum:</a:t>
+            </a:r>
+            <a:r>
+              <a:rPr lang="tr-TR" sz="4800" dirty="0"/>
+              <a:t> MLP'nin daha fazla veri veya daha fazla katmanla iyileştirilebilir olduğunu gösterebilir</a:t>
+            </a:r>
+          </a:p>
           <a:p>
             <a:endParaRPr lang="tr-TR" dirty="0"/>
           </a:p>
@@ -5354,7 +5711,7 @@
     </p:spTree>
     <p:extLst>
       <p:ext uri="{BB962C8B-B14F-4D97-AF65-F5344CB8AC3E}">
-        <p14:creationId xmlns:p14="http://schemas.microsoft.com/office/powerpoint/2010/main" val="3458459640"/>
+        <p14:creationId xmlns:p14="http://schemas.microsoft.com/office/powerpoint/2010/main" val="2597987520"/>
       </p:ext>
     </p:extLst>
   </p:cSld>
@@ -5386,7 +5743,7 @@
           <p:cNvPr id="2" name="Title 1">
             <a:extLst>
               <a:ext uri="{FF2B5EF4-FFF2-40B4-BE49-F238E27FC236}">
-                <a16:creationId xmlns:a16="http://schemas.microsoft.com/office/drawing/2014/main" id="{00B47676-C309-59AB-A1AB-3905CD9603B1}"/>
+                <a16:creationId xmlns:a16="http://schemas.microsoft.com/office/drawing/2014/main" id="{E1445F4C-E697-4109-128B-20373D6DC156}"/>
               </a:ext>
             </a:extLst>
           </p:cNvPr>
@@ -5402,7 +5759,15 @@
           <a:bodyPr/>
           <a:lstStyle/>
           <a:p>
-            <a:endParaRPr lang="tr-TR"/>
+            <a:r>
+              <a:rPr lang="tr-TR" dirty="0"/>
+              <a:t>7. </a:t>
+            </a:r>
+            <a:r>
+              <a:rPr lang="tr-TR" b="1" dirty="0"/>
+              <a:t>Test Sonuçları ve Karşılaştırmalı Tablo(DATASET-11)</a:t>
+            </a:r>
+            <a:endParaRPr lang="tr-TR" dirty="0"/>
           </a:p>
         </p:txBody>
       </p:sp>
@@ -5411,7 +5776,7 @@
           <p:cNvPr id="3" name="Content Placeholder 2">
             <a:extLst>
               <a:ext uri="{FF2B5EF4-FFF2-40B4-BE49-F238E27FC236}">
-                <a16:creationId xmlns:a16="http://schemas.microsoft.com/office/drawing/2014/main" id="{748E7F61-953B-CB89-FE9B-AF7DCD9E8545}"/>
+                <a16:creationId xmlns:a16="http://schemas.microsoft.com/office/drawing/2014/main" id="{1768779C-421B-3BFB-29F7-628065996A5B}"/>
               </a:ext>
             </a:extLst>
           </p:cNvPr>
@@ -5427,44 +5792,14 @@
           <a:bodyPr/>
           <a:lstStyle/>
           <a:p>
-            <a:endParaRPr lang="tr-TR"/>
-          </a:p>
-        </p:txBody>
-      </p:sp>
-      <p:pic>
-        <p:nvPicPr>
-          <p:cNvPr id="5" name="Content Placeholder 4">
-            <a:extLst>
-              <a:ext uri="{FF2B5EF4-FFF2-40B4-BE49-F238E27FC236}">
-                <a16:creationId xmlns:a16="http://schemas.microsoft.com/office/drawing/2014/main" id="{D8C1991D-2CCC-DBA3-3472-2F08242966F5}"/>
-              </a:ext>
-            </a:extLst>
-          </p:cNvPr>
-          <p:cNvPicPr>
-            <a:picLocks noChangeAspect="1"/>
-          </p:cNvPicPr>
-          <p:nvPr/>
-        </p:nvPicPr>
-        <p:blipFill>
-          <a:blip r:embed="rId2"/>
-          <a:stretch>
-            <a:fillRect/>
-          </a:stretch>
-        </p:blipFill>
-        <p:spPr>
-          <a:xfrm>
-            <a:off x="0" y="0"/>
-            <a:ext cx="12192000" cy="6931742"/>
-          </a:xfrm>
-          <a:prstGeom prst="rect">
-            <a:avLst/>
-          </a:prstGeom>
-        </p:spPr>
-      </p:pic>
+            <a:endParaRPr lang="tr-TR" dirty="0"/>
+          </a:p>
+        </p:txBody>
+      </p:sp>
     </p:spTree>
     <p:extLst>
       <p:ext uri="{BB962C8B-B14F-4D97-AF65-F5344CB8AC3E}">
-        <p14:creationId xmlns:p14="http://schemas.microsoft.com/office/powerpoint/2010/main" val="2444073378"/>
+        <p14:creationId xmlns:p14="http://schemas.microsoft.com/office/powerpoint/2010/main" val="3458459640"/>
       </p:ext>
     </p:extLst>
   </p:cSld>

</xml_diff>